<commit_message>
Apply colleague feedback and add Q&A study guide
- Relabel groups: TRG -> Verdant -> The Nature Conservancy (Heartlands); Other private -> kept
- Add Molpus and Lyme to by-year charts; note Molpus 2025 canopy drop
- Drop-year maps: discrete year legend, Canopy Cover Loss titles, faceted USFS/Hansen panels, larger Heartlands maps
- Define other private owners (Lake Superior Timberlands holds 69% of kept acres)
- Add reference/qa_study_guide.md

Co-authored-by: Cursor <cursoragent@cursor.com>
</commit_message>
<xml_diff>
--- a/output_visuals/powerpoint/02_heavily_cut_share.pptx
+++ b/output_visuals/powerpoint/02_heavily_cut_share.pptx
@@ -2297,7 +2297,7 @@
           </p:nvSpPr>
           <p:spPr>
             <a:xfrm>
-              <a:off x="4933717" y="1681489"/>
+              <a:off x="5913863" y="1681489"/>
               <a:ext cx="0" cy="3920204"/>
             </a:xfrm>
             <a:custGeom>
@@ -2340,7 +2340,7 @@
           </p:nvSpPr>
           <p:spPr>
             <a:xfrm>
-              <a:off x="6712537" y="1681489"/>
+              <a:off x="7425880" y="1681489"/>
               <a:ext cx="0" cy="3920204"/>
             </a:xfrm>
             <a:custGeom>
@@ -2383,7 +2383,7 @@
           </p:nvSpPr>
           <p:spPr>
             <a:xfrm>
-              <a:off x="8491358" y="1681489"/>
+              <a:off x="8937898" y="1681489"/>
               <a:ext cx="0" cy="3920204"/>
             </a:xfrm>
             <a:custGeom>
@@ -2426,7 +2426,7 @@
           </p:nvSpPr>
           <p:spPr>
             <a:xfrm>
-              <a:off x="10270178" y="1681489"/>
+              <a:off x="10449916" y="1681489"/>
               <a:ext cx="0" cy="3920204"/>
             </a:xfrm>
             <a:custGeom>
@@ -2469,8 +2469,8 @@
           </p:nvSpPr>
           <p:spPr>
             <a:xfrm>
-              <a:off x="4933717" y="2279081"/>
-              <a:ext cx="3588428" cy="334651"/>
+              <a:off x="5913863" y="2279081"/>
+              <a:ext cx="3050205" cy="334651"/>
             </a:xfrm>
             <a:prstGeom prst="rect">
               <a:avLst/>
@@ -2495,8 +2495,8 @@
           </p:nvSpPr>
           <p:spPr>
             <a:xfrm>
-              <a:off x="4933717" y="1801007"/>
-              <a:ext cx="4506764" cy="334651"/>
+              <a:off x="5913863" y="1801007"/>
+              <a:ext cx="3830802" cy="334651"/>
             </a:xfrm>
             <a:prstGeom prst="rect">
               <a:avLst/>
@@ -2521,8 +2521,8 @@
           </p:nvSpPr>
           <p:spPr>
             <a:xfrm>
-              <a:off x="4933717" y="2757155"/>
-              <a:ext cx="1200624" cy="334651"/>
+              <a:off x="5913863" y="2757155"/>
+              <a:ext cx="1020544" cy="334651"/>
             </a:xfrm>
             <a:prstGeom prst="rect">
               <a:avLst/>
@@ -2547,8 +2547,8 @@
           </p:nvSpPr>
           <p:spPr>
             <a:xfrm>
-              <a:off x="4933717" y="4669450"/>
-              <a:ext cx="46938" cy="334651"/>
+              <a:off x="5913863" y="4669450"/>
+              <a:ext cx="39897" cy="334651"/>
             </a:xfrm>
             <a:prstGeom prst="rect">
               <a:avLst/>
@@ -2573,8 +2573,8 @@
           </p:nvSpPr>
           <p:spPr>
             <a:xfrm>
-              <a:off x="4933717" y="3235229"/>
-              <a:ext cx="421941" cy="334651"/>
+              <a:off x="5913863" y="3235229"/>
+              <a:ext cx="358655" cy="334651"/>
             </a:xfrm>
             <a:prstGeom prst="rect">
               <a:avLst/>
@@ -2599,7 +2599,7 @@
           </p:nvSpPr>
           <p:spPr>
             <a:xfrm>
-              <a:off x="4933717" y="5147524"/>
+              <a:off x="5913863" y="5147524"/>
               <a:ext cx="0" cy="334651"/>
             </a:xfrm>
             <a:prstGeom prst="rect">
@@ -2625,8 +2625,8 @@
           </p:nvSpPr>
           <p:spPr>
             <a:xfrm>
-              <a:off x="4933717" y="3713302"/>
-              <a:ext cx="160903" cy="334651"/>
+              <a:off x="5913863" y="3713302"/>
+              <a:ext cx="136769" cy="334651"/>
             </a:xfrm>
             <a:prstGeom prst="rect">
               <a:avLst/>
@@ -2651,8 +2651,8 @@
           </p:nvSpPr>
           <p:spPr>
             <a:xfrm>
-              <a:off x="4933717" y="4191376"/>
-              <a:ext cx="60752" cy="334651"/>
+              <a:off x="5913863" y="4191376"/>
+              <a:ext cx="51640" cy="334651"/>
             </a:xfrm>
             <a:prstGeom prst="rect">
               <a:avLst/>
@@ -2677,7 +2677,7 @@
           </p:nvSpPr>
           <p:spPr>
             <a:xfrm>
-              <a:off x="8621198" y="2380570"/>
+              <a:off x="9063121" y="2380570"/>
               <a:ext cx="1981047" cy="131673"/>
             </a:xfrm>
             <a:prstGeom prst="rect">
@@ -2720,7 +2720,7 @@
           </p:nvSpPr>
           <p:spPr>
             <a:xfrm>
-              <a:off x="9533788" y="1902496"/>
+              <a:off x="9837971" y="1902496"/>
               <a:ext cx="1866107" cy="131673"/>
             </a:xfrm>
             <a:prstGeom prst="rect">
@@ -2763,7 +2763,7 @@
           </p:nvSpPr>
           <p:spPr>
             <a:xfrm>
-              <a:off x="6239141" y="2858644"/>
+              <a:off x="7039207" y="2858644"/>
               <a:ext cx="2095987" cy="131673"/>
             </a:xfrm>
             <a:prstGeom prst="rect">
@@ -2806,7 +2806,7 @@
           </p:nvSpPr>
           <p:spPr>
             <a:xfrm>
-              <a:off x="5065342" y="4770939"/>
+              <a:off x="6038448" y="4770939"/>
               <a:ext cx="1693743" cy="131673"/>
             </a:xfrm>
             <a:prstGeom prst="rect">
@@ -2849,7 +2849,7 @@
           </p:nvSpPr>
           <p:spPr>
             <a:xfrm>
-              <a:off x="5434599" y="3336718"/>
+              <a:off x="6351458" y="3336718"/>
               <a:ext cx="1578803" cy="131673"/>
             </a:xfrm>
             <a:prstGeom prst="rect">
@@ -2892,7 +2892,7 @@
           </p:nvSpPr>
           <p:spPr>
             <a:xfrm>
-              <a:off x="5012657" y="5249013"/>
+              <a:off x="5992803" y="5249013"/>
               <a:ext cx="1578803" cy="131673"/>
             </a:xfrm>
             <a:prstGeom prst="rect">
@@ -2935,7 +2935,7 @@
           </p:nvSpPr>
           <p:spPr>
             <a:xfrm>
-              <a:off x="5185055" y="3814791"/>
+              <a:off x="6141067" y="3814791"/>
               <a:ext cx="1808683" cy="131673"/>
             </a:xfrm>
             <a:prstGeom prst="rect">
@@ -2978,7 +2978,7 @@
           </p:nvSpPr>
           <p:spPr>
             <a:xfrm>
-              <a:off x="5084904" y="4292865"/>
+              <a:off x="6055937" y="4292865"/>
               <a:ext cx="1808683" cy="131673"/>
             </a:xfrm>
             <a:prstGeom prst="rect">
@@ -3022,7 +3022,7 @@
           <p:spPr>
             <a:xfrm>
               <a:off x="723472" y="5248235"/>
-              <a:ext cx="4107759" cy="133228"/>
+              <a:ext cx="5087904" cy="133228"/>
             </a:xfrm>
             <a:prstGeom prst="rect">
               <a:avLst/>
@@ -3051,7 +3051,7 @@
                   <a:latin typeface="DejaVu Sans"/>
                   <a:cs typeface="DejaVu Sans"/>
                 </a:rPr>
-                <a:t>TRG → The Nature Conservancy (Heartlands)</a:t>
+                <a:t>TRG → Verdant → The Nature Conservancy (Heartlands)</a:t>
               </a:r>
             </a:p>
           </p:txBody>
@@ -3064,7 +3064,7 @@
           </p:nvSpPr>
           <p:spPr>
             <a:xfrm>
-              <a:off x="2101748" y="4770162"/>
+              <a:off x="3081893" y="4770162"/>
               <a:ext cx="2729484" cy="133228"/>
             </a:xfrm>
             <a:prstGeom prst="rect">
@@ -3107,8 +3107,8 @@
           </p:nvSpPr>
           <p:spPr>
             <a:xfrm>
-              <a:off x="2217968" y="4292088"/>
-              <a:ext cx="2613263" cy="133228"/>
+              <a:off x="3919118" y="4292088"/>
+              <a:ext cx="1892259" cy="133228"/>
             </a:xfrm>
             <a:prstGeom prst="rect">
               <a:avLst/>
@@ -3137,7 +3137,7 @@
                   <a:latin typeface="DejaVu Sans"/>
                   <a:cs typeface="DejaVu Sans"/>
                 </a:rPr>
-                <a:t>Other private → same owner</a:t>
+                <a:t>Other private → kept</a:t>
               </a:r>
             </a:p>
           </p:txBody>
@@ -3150,8 +3150,8 @@
           </p:nvSpPr>
           <p:spPr>
             <a:xfrm>
-              <a:off x="1463039" y="3814014"/>
-              <a:ext cx="3368192" cy="133228"/>
+              <a:off x="2944642" y="3814014"/>
+              <a:ext cx="2866735" cy="133228"/>
             </a:xfrm>
             <a:prstGeom prst="rect">
               <a:avLst/>
@@ -3180,7 +3180,7 @@
                   <a:latin typeface="DejaVu Sans"/>
                   <a:cs typeface="DejaVu Sans"/>
                 </a:rPr>
-                <a:t>Other private → new owner / left CFP</a:t>
+                <a:t>Other private → sold or left CFP</a:t>
               </a:r>
             </a:p>
           </p:txBody>
@@ -3193,8 +3193,8 @@
           </p:nvSpPr>
           <p:spPr>
             <a:xfrm>
-              <a:off x="3594323" y="3335940"/>
-              <a:ext cx="1236908" cy="133228"/>
+              <a:off x="4658684" y="3335940"/>
+              <a:ext cx="1152692" cy="133228"/>
             </a:xfrm>
             <a:prstGeom prst="rect">
               <a:avLst/>
@@ -3223,7 +3223,7 @@
                   <a:latin typeface="DejaVu Sans"/>
                   <a:cs typeface="DejaVu Sans"/>
                 </a:rPr>
-                <a:t>Lyme → Lyme</a:t>
+                <a:t>Lyme → kept</a:t>
               </a:r>
             </a:p>
           </p:txBody>
@@ -3236,7 +3236,7 @@
           </p:nvSpPr>
           <p:spPr>
             <a:xfrm>
-              <a:off x="3470787" y="2857867"/>
+              <a:off x="4450933" y="2857867"/>
               <a:ext cx="1360444" cy="133228"/>
             </a:xfrm>
             <a:prstGeom prst="rect">
@@ -3279,7 +3279,7 @@
           </p:nvSpPr>
           <p:spPr>
             <a:xfrm>
-              <a:off x="793150" y="2379793"/>
+              <a:off x="1773295" y="2379793"/>
               <a:ext cx="4038081" cy="133228"/>
             </a:xfrm>
             <a:prstGeom prst="rect">
@@ -3322,8 +3322,8 @@
           </p:nvSpPr>
           <p:spPr>
             <a:xfrm>
-              <a:off x="2666847" y="1901719"/>
-              <a:ext cx="2164384" cy="133228"/>
+              <a:off x="4495098" y="1901719"/>
+              <a:ext cx="1316278" cy="133228"/>
             </a:xfrm>
             <a:prstGeom prst="rect">
               <a:avLst/>
@@ -3352,7 +3352,7 @@
                   <a:latin typeface="DejaVu Sans"/>
                   <a:cs typeface="DejaVu Sans"/>
                 </a:rPr>
-                <a:t>Molpus → Molpus (kept)</a:t>
+                <a:t>Molpus → kept</a:t>
               </a:r>
             </a:p>
           </p:txBody>
@@ -3365,7 +3365,7 @@
           </p:nvSpPr>
           <p:spPr>
             <a:xfrm>
-              <a:off x="4788739" y="5704179"/>
+              <a:off x="5768885" y="5704179"/>
               <a:ext cx="289956" cy="133228"/>
             </a:xfrm>
             <a:prstGeom prst="rect">
@@ -3408,7 +3408,7 @@
           </p:nvSpPr>
           <p:spPr>
             <a:xfrm>
-              <a:off x="6509403" y="5704179"/>
+              <a:off x="7222746" y="5704179"/>
               <a:ext cx="406267" cy="133228"/>
             </a:xfrm>
             <a:prstGeom prst="rect">
@@ -3451,7 +3451,7 @@
           </p:nvSpPr>
           <p:spPr>
             <a:xfrm>
-              <a:off x="8288224" y="5704179"/>
+              <a:off x="8734764" y="5704179"/>
               <a:ext cx="406267" cy="133228"/>
             </a:xfrm>
             <a:prstGeom prst="rect">
@@ -3494,7 +3494,7 @@
           </p:nvSpPr>
           <p:spPr>
             <a:xfrm>
-              <a:off x="10067044" y="5704179"/>
+              <a:off x="10246782" y="5704179"/>
               <a:ext cx="406267" cy="133228"/>
             </a:xfrm>
             <a:prstGeom prst="rect">

</xml_diff>